<commit_message>
refactor(custom-attn): deepen flexattention and rebuild deck
</commit_message>
<xml_diff>
--- a/01_ai_infra/kernel/custom_attn/supplements/multimodal-custom-attention.pptx
+++ b/01_ai_infra/kernel/custom_attn/supplements/multimodal-custom-attention.pptx
@@ -3192,8 +3192,8 @@
         </p:nvSpPr>
         <p:spPr>
           <a:xfrm>
-            <a:off x="8065008" y="3657600"/>
-            <a:ext cx="3337560" cy="438912"/>
+            <a:off x="7973568" y="3566160"/>
+            <a:ext cx="3493008" cy="530352"/>
           </a:xfrm>
           <a:prstGeom prst="roundRect">
             <a:avLst/>
@@ -3237,7 +3237,7 @@
         </p:nvSpPr>
         <p:spPr>
           <a:xfrm>
-            <a:off x="8266175" y="3767328"/>
+            <a:off x="8174736" y="3712463"/>
             <a:ext cx="594360" cy="164592"/>
           </a:xfrm>
           <a:prstGeom prst="rect">
@@ -3253,7 +3253,7 @@
           <a:p>
             <a:pPr algn="l"/>
             <a:r>
-              <a:rPr sz="1300" b="1">
+              <a:rPr sz="1200" b="1">
                 <a:solidFill>
                   <a:srgbClr val="17212B"/>
                 </a:solidFill>
@@ -3272,23 +3272,23 @@
         </p:nvSpPr>
         <p:spPr>
           <a:xfrm>
-            <a:off x="8915400" y="3712464"/>
-            <a:ext cx="2286000" cy="320040"/>
-          </a:xfrm>
-          <a:prstGeom prst="rect">
-            <a:avLst/>
-          </a:prstGeom>
-          <a:noFill/>
-        </p:spPr>
-        <p:txBody>
-          <a:bodyPr wrap="square" lIns="36576" rIns="36576" tIns="36576" bIns="36576" anchor="t">
-            <a:spAutoFit/>
-          </a:bodyPr>
-          <a:lstStyle/>
-          <a:p>
-            <a:pPr algn="l"/>
-            <a:r>
-              <a:rPr sz="900" b="0">
+            <a:off x="8796528" y="3648456"/>
+            <a:ext cx="2487168" cy="347472"/>
+          </a:xfrm>
+          <a:prstGeom prst="rect">
+            <a:avLst/>
+          </a:prstGeom>
+          <a:noFill/>
+        </p:spPr>
+        <p:txBody>
+          <a:bodyPr wrap="square" lIns="36576" rIns="36576" tIns="36576" bIns="36576" anchor="ctr">
+            <a:spAutoFit/>
+          </a:bodyPr>
+          <a:lstStyle/>
+          <a:p>
+            <a:pPr algn="l"/>
+            <a:r>
+              <a:rPr sz="1000" b="0">
                 <a:solidFill>
                   <a:srgbClr val="17212B"/>
                 </a:solidFill>
@@ -3307,8 +3307,8 @@
         </p:nvSpPr>
         <p:spPr>
           <a:xfrm>
-            <a:off x="8065008" y="4315968"/>
-            <a:ext cx="3337560" cy="438912"/>
+            <a:off x="7973568" y="4279392"/>
+            <a:ext cx="3493008" cy="530352"/>
           </a:xfrm>
           <a:prstGeom prst="roundRect">
             <a:avLst/>
@@ -3352,7 +3352,7 @@
         </p:nvSpPr>
         <p:spPr>
           <a:xfrm>
-            <a:off x="8266175" y="4425696"/>
+            <a:off x="8174736" y="4425696"/>
             <a:ext cx="594360" cy="164592"/>
           </a:xfrm>
           <a:prstGeom prst="rect">
@@ -3368,7 +3368,7 @@
           <a:p>
             <a:pPr algn="l"/>
             <a:r>
-              <a:rPr sz="1300" b="1">
+              <a:rPr sz="1200" b="1">
                 <a:solidFill>
                   <a:srgbClr val="17212B"/>
                 </a:solidFill>
@@ -3387,23 +3387,23 @@
         </p:nvSpPr>
         <p:spPr>
           <a:xfrm>
-            <a:off x="8915400" y="4370832"/>
-            <a:ext cx="2286000" cy="320040"/>
-          </a:xfrm>
-          <a:prstGeom prst="rect">
-            <a:avLst/>
-          </a:prstGeom>
-          <a:noFill/>
-        </p:spPr>
-        <p:txBody>
-          <a:bodyPr wrap="square" lIns="36576" rIns="36576" tIns="36576" bIns="36576" anchor="t">
-            <a:spAutoFit/>
-          </a:bodyPr>
-          <a:lstStyle/>
-          <a:p>
-            <a:pPr algn="l"/>
-            <a:r>
-              <a:rPr sz="900" b="0">
+            <a:off x="8796528" y="4361688"/>
+            <a:ext cx="2487168" cy="347472"/>
+          </a:xfrm>
+          <a:prstGeom prst="rect">
+            <a:avLst/>
+          </a:prstGeom>
+          <a:noFill/>
+        </p:spPr>
+        <p:txBody>
+          <a:bodyPr wrap="square" lIns="36576" rIns="36576" tIns="36576" bIns="36576" anchor="ctr">
+            <a:spAutoFit/>
+          </a:bodyPr>
+          <a:lstStyle/>
+          <a:p>
+            <a:pPr algn="l"/>
+            <a:r>
+              <a:rPr sz="1000" b="0">
                 <a:solidFill>
                   <a:srgbClr val="17212B"/>
                 </a:solidFill>
@@ -3422,8 +3422,8 @@
         </p:nvSpPr>
         <p:spPr>
           <a:xfrm>
-            <a:off x="8065008" y="4974336"/>
-            <a:ext cx="3337560" cy="438912"/>
+            <a:off x="7973568" y="4992624"/>
+            <a:ext cx="3493008" cy="530352"/>
           </a:xfrm>
           <a:prstGeom prst="roundRect">
             <a:avLst/>
@@ -3467,7 +3467,7 @@
         </p:nvSpPr>
         <p:spPr>
           <a:xfrm>
-            <a:off x="8266175" y="5084064"/>
+            <a:off x="8174736" y="5138928"/>
             <a:ext cx="594360" cy="164592"/>
           </a:xfrm>
           <a:prstGeom prst="rect">
@@ -3483,7 +3483,7 @@
           <a:p>
             <a:pPr algn="l"/>
             <a:r>
-              <a:rPr sz="1300" b="1">
+              <a:rPr sz="1200" b="1">
                 <a:solidFill>
                   <a:srgbClr val="17212B"/>
                 </a:solidFill>
@@ -3502,23 +3502,23 @@
         </p:nvSpPr>
         <p:spPr>
           <a:xfrm>
-            <a:off x="8915400" y="5029200"/>
-            <a:ext cx="2286000" cy="320040"/>
-          </a:xfrm>
-          <a:prstGeom prst="rect">
-            <a:avLst/>
-          </a:prstGeom>
-          <a:noFill/>
-        </p:spPr>
-        <p:txBody>
-          <a:bodyPr wrap="square" lIns="36576" rIns="36576" tIns="36576" bIns="36576" anchor="t">
-            <a:spAutoFit/>
-          </a:bodyPr>
-          <a:lstStyle/>
-          <a:p>
-            <a:pPr algn="l"/>
-            <a:r>
-              <a:rPr sz="900" b="0">
+            <a:off x="8796528" y="5074920"/>
+            <a:ext cx="2487168" cy="347472"/>
+          </a:xfrm>
+          <a:prstGeom prst="rect">
+            <a:avLst/>
+          </a:prstGeom>
+          <a:noFill/>
+        </p:spPr>
+        <p:txBody>
+          <a:bodyPr wrap="square" lIns="36576" rIns="36576" tIns="36576" bIns="36576" anchor="ctr">
+            <a:spAutoFit/>
+          </a:bodyPr>
+          <a:lstStyle/>
+          <a:p>
+            <a:pPr algn="l"/>
+            <a:r>
+              <a:rPr sz="1000" b="0">
                 <a:solidFill>
                   <a:srgbClr val="17212B"/>
                 </a:solidFill>
@@ -3572,7 +3572,7 @@
         </p:nvSpPr>
         <p:spPr>
           <a:xfrm>
-            <a:off x="11356848" y="6409944"/>
+            <a:off x="11356848" y="6217920"/>
             <a:ext cx="320040" cy="182880"/>
           </a:xfrm>
           <a:prstGeom prst="rect">
@@ -3633,29 +3633,29 @@
         </p:nvSpPr>
         <p:spPr>
           <a:xfrm>
-            <a:off x="502920" y="256032"/>
-            <a:ext cx="10881360" cy="411480"/>
-          </a:xfrm>
-          <a:prstGeom prst="rect">
-            <a:avLst/>
-          </a:prstGeom>
-          <a:noFill/>
-        </p:spPr>
-        <p:txBody>
-          <a:bodyPr wrap="square" lIns="36576" rIns="36576" tIns="36576" bIns="36576" anchor="t">
-            <a:spAutoFit/>
-          </a:bodyPr>
-          <a:lstStyle/>
-          <a:p>
-            <a:pPr algn="l"/>
-            <a:r>
-              <a:rPr sz="2100" b="1">
+            <a:off x="502920" y="182880"/>
+            <a:ext cx="11109960" cy="640080"/>
+          </a:xfrm>
+          <a:prstGeom prst="rect">
+            <a:avLst/>
+          </a:prstGeom>
+          <a:noFill/>
+        </p:spPr>
+        <p:txBody>
+          <a:bodyPr wrap="square" lIns="36576" rIns="36576" tIns="36576" bIns="36576" anchor="t">
+            <a:spAutoFit/>
+          </a:bodyPr>
+          <a:lstStyle/>
+          <a:p>
+            <a:pPr algn="l"/>
+            <a:r>
+              <a:rPr sz="2400" b="1">
                 <a:solidFill>
                   <a:srgbClr val="17212B"/>
                 </a:solidFill>
                 <a:latin typeface="Aptos Display"/>
               </a:rPr>
-              <a:t>Training-free 视频：Sparse VideoGen 的 spatial / temporal head dispatch</a:t>
+              <a:t>Sparse VideoGen：spatial / temporal head dispatch</a:t>
             </a:r>
           </a:p>
         </p:txBody>
@@ -3668,23 +3668,23 @@
         </p:nvSpPr>
         <p:spPr>
           <a:xfrm>
-            <a:off x="530352" y="804672"/>
-            <a:ext cx="10789920" cy="201168"/>
-          </a:xfrm>
-          <a:prstGeom prst="rect">
-            <a:avLst/>
-          </a:prstGeom>
-          <a:noFill/>
-        </p:spPr>
-        <p:txBody>
-          <a:bodyPr wrap="square" lIns="36576" rIns="36576" tIns="36576" bIns="36576" anchor="t">
-            <a:spAutoFit/>
-          </a:bodyPr>
-          <a:lstStyle/>
-          <a:p>
-            <a:pPr algn="l"/>
-            <a:r>
-              <a:rPr sz="900" b="0">
+            <a:off x="530352" y="896112"/>
+            <a:ext cx="10789920" cy="164592"/>
+          </a:xfrm>
+          <a:prstGeom prst="rect">
+            <a:avLst/>
+          </a:prstGeom>
+          <a:noFill/>
+        </p:spPr>
+        <p:txBody>
+          <a:bodyPr wrap="square" lIns="36576" rIns="36576" tIns="36576" bIns="36576" anchor="t">
+            <a:spAutoFit/>
+          </a:bodyPr>
+          <a:lstStyle/>
+          <a:p>
+            <a:pPr algn="l"/>
+            <a:r>
+              <a:rPr sz="800" b="0">
                 <a:solidFill>
                   <a:srgbClr val="52616B"/>
                 </a:solidFill>
@@ -4252,7 +4252,7 @@
         </p:nvSpPr>
         <p:spPr>
           <a:xfrm>
-            <a:off x="530352" y="6437376"/>
+            <a:off x="530352" y="6236208"/>
             <a:ext cx="10607040" cy="164592"/>
           </a:xfrm>
           <a:prstGeom prst="rect">
@@ -4287,7 +4287,7 @@
         </p:nvSpPr>
         <p:spPr>
           <a:xfrm>
-            <a:off x="11356848" y="6409944"/>
+            <a:off x="11356848" y="6217920"/>
             <a:ext cx="320040" cy="182880"/>
           </a:xfrm>
           <a:prstGeom prst="rect">
@@ -4348,23 +4348,23 @@
         </p:nvSpPr>
         <p:spPr>
           <a:xfrm>
-            <a:off x="502920" y="256032"/>
-            <a:ext cx="10881360" cy="411480"/>
-          </a:xfrm>
-          <a:prstGeom prst="rect">
-            <a:avLst/>
-          </a:prstGeom>
-          <a:noFill/>
-        </p:spPr>
-        <p:txBody>
-          <a:bodyPr wrap="square" lIns="36576" rIns="36576" tIns="36576" bIns="36576" anchor="t">
-            <a:spAutoFit/>
-          </a:bodyPr>
-          <a:lstStyle/>
-          <a:p>
-            <a:pPr algn="l"/>
-            <a:r>
-              <a:rPr sz="2200" b="1">
+            <a:off x="502920" y="182880"/>
+            <a:ext cx="11109960" cy="640080"/>
+          </a:xfrm>
+          <a:prstGeom prst="rect">
+            <a:avLst/>
+          </a:prstGeom>
+          <a:noFill/>
+        </p:spPr>
+        <p:txBody>
+          <a:bodyPr wrap="square" lIns="36576" rIns="36576" tIns="36576" bIns="36576" anchor="t">
+            <a:spAutoFit/>
+          </a:bodyPr>
+          <a:lstStyle/>
+          <a:p>
+            <a:pPr algn="l"/>
+            <a:r>
+              <a:rPr sz="2400" b="1">
                 <a:solidFill>
                   <a:srgbClr val="17212B"/>
                 </a:solidFill>
@@ -4383,23 +4383,23 @@
         </p:nvSpPr>
         <p:spPr>
           <a:xfrm>
-            <a:off x="530352" y="804672"/>
-            <a:ext cx="10789920" cy="201168"/>
-          </a:xfrm>
-          <a:prstGeom prst="rect">
-            <a:avLst/>
-          </a:prstGeom>
-          <a:noFill/>
-        </p:spPr>
-        <p:txBody>
-          <a:bodyPr wrap="square" lIns="36576" rIns="36576" tIns="36576" bIns="36576" anchor="t">
-            <a:spAutoFit/>
-          </a:bodyPr>
-          <a:lstStyle/>
-          <a:p>
-            <a:pPr algn="l"/>
-            <a:r>
-              <a:rPr sz="900" b="0">
+            <a:off x="530352" y="896112"/>
+            <a:ext cx="10789920" cy="164592"/>
+          </a:xfrm>
+          <a:prstGeom prst="rect">
+            <a:avLst/>
+          </a:prstGeom>
+          <a:noFill/>
+        </p:spPr>
+        <p:txBody>
+          <a:bodyPr wrap="square" lIns="36576" rIns="36576" tIns="36576" bIns="36576" anchor="t">
+            <a:spAutoFit/>
+          </a:bodyPr>
+          <a:lstStyle/>
+          <a:p>
+            <a:pPr algn="l"/>
+            <a:r>
+              <a:rPr sz="800" b="0">
                 <a:solidFill>
                   <a:srgbClr val="52616B"/>
                 </a:solidFill>
@@ -4967,7 +4967,7 @@
         </p:nvSpPr>
         <p:spPr>
           <a:xfrm>
-            <a:off x="530352" y="6437376"/>
+            <a:off x="530352" y="6236208"/>
             <a:ext cx="10607040" cy="164592"/>
           </a:xfrm>
           <a:prstGeom prst="rect">
@@ -5002,7 +5002,7 @@
         </p:nvSpPr>
         <p:spPr>
           <a:xfrm>
-            <a:off x="11356848" y="6409944"/>
+            <a:off x="11356848" y="6217920"/>
             <a:ext cx="320040" cy="182880"/>
           </a:xfrm>
           <a:prstGeom prst="rect">
@@ -5063,23 +5063,23 @@
         </p:nvSpPr>
         <p:spPr>
           <a:xfrm>
-            <a:off x="502920" y="256032"/>
-            <a:ext cx="10881360" cy="411480"/>
-          </a:xfrm>
-          <a:prstGeom prst="rect">
-            <a:avLst/>
-          </a:prstGeom>
-          <a:noFill/>
-        </p:spPr>
-        <p:txBody>
-          <a:bodyPr wrap="square" lIns="36576" rIns="36576" tIns="36576" bIns="36576" anchor="t">
-            <a:spAutoFit/>
-          </a:bodyPr>
-          <a:lstStyle/>
-          <a:p>
-            <a:pPr algn="l"/>
-            <a:r>
-              <a:rPr sz="2200" b="1">
+            <a:off x="502920" y="182880"/>
+            <a:ext cx="11109960" cy="640080"/>
+          </a:xfrm>
+          <a:prstGeom prst="rect">
+            <a:avLst/>
+          </a:prstGeom>
+          <a:noFill/>
+        </p:spPr>
+        <p:txBody>
+          <a:bodyPr wrap="square" lIns="36576" rIns="36576" tIns="36576" bIns="36576" anchor="t">
+            <a:spAutoFit/>
+          </a:bodyPr>
+          <a:lstStyle/>
+          <a:p>
+            <a:pPr algn="l"/>
+            <a:r>
+              <a:rPr sz="2400" b="1">
                 <a:solidFill>
                   <a:srgbClr val="17212B"/>
                 </a:solidFill>
@@ -5098,23 +5098,23 @@
         </p:nvSpPr>
         <p:spPr>
           <a:xfrm>
-            <a:off x="530352" y="804672"/>
-            <a:ext cx="10789920" cy="201168"/>
-          </a:xfrm>
-          <a:prstGeom prst="rect">
-            <a:avLst/>
-          </a:prstGeom>
-          <a:noFill/>
-        </p:spPr>
-        <p:txBody>
-          <a:bodyPr wrap="square" lIns="36576" rIns="36576" tIns="36576" bIns="36576" anchor="t">
-            <a:spAutoFit/>
-          </a:bodyPr>
-          <a:lstStyle/>
-          <a:p>
-            <a:pPr algn="l"/>
-            <a:r>
-              <a:rPr sz="900" b="0">
+            <a:off x="530352" y="896112"/>
+            <a:ext cx="10789920" cy="164592"/>
+          </a:xfrm>
+          <a:prstGeom prst="rect">
+            <a:avLst/>
+          </a:prstGeom>
+          <a:noFill/>
+        </p:spPr>
+        <p:txBody>
+          <a:bodyPr wrap="square" lIns="36576" rIns="36576" tIns="36576" bIns="36576" anchor="t">
+            <a:spAutoFit/>
+          </a:bodyPr>
+          <a:lstStyle/>
+          <a:p>
+            <a:pPr algn="l"/>
+            <a:r>
+              <a:rPr sz="800" b="0">
                 <a:solidFill>
                   <a:srgbClr val="52616B"/>
                 </a:solidFill>
@@ -5682,7 +5682,7 @@
         </p:nvSpPr>
         <p:spPr>
           <a:xfrm>
-            <a:off x="530352" y="6437376"/>
+            <a:off x="530352" y="6236208"/>
             <a:ext cx="10607040" cy="164592"/>
           </a:xfrm>
           <a:prstGeom prst="rect">
@@ -5717,7 +5717,7 @@
         </p:nvSpPr>
         <p:spPr>
           <a:xfrm>
-            <a:off x="11356848" y="6409944"/>
+            <a:off x="11356848" y="6217920"/>
             <a:ext cx="320040" cy="182880"/>
           </a:xfrm>
           <a:prstGeom prst="rect">
@@ -5778,23 +5778,23 @@
         </p:nvSpPr>
         <p:spPr>
           <a:xfrm>
-            <a:off x="502920" y="256032"/>
-            <a:ext cx="10881360" cy="411480"/>
-          </a:xfrm>
-          <a:prstGeom prst="rect">
-            <a:avLst/>
-          </a:prstGeom>
-          <a:noFill/>
-        </p:spPr>
-        <p:txBody>
-          <a:bodyPr wrap="square" lIns="36576" rIns="36576" tIns="36576" bIns="36576" anchor="t">
-            <a:spAutoFit/>
-          </a:bodyPr>
-          <a:lstStyle/>
-          <a:p>
-            <a:pPr algn="l"/>
-            <a:r>
-              <a:rPr sz="2200" b="1">
+            <a:off x="502920" y="182880"/>
+            <a:ext cx="11109960" cy="640080"/>
+          </a:xfrm>
+          <a:prstGeom prst="rect">
+            <a:avLst/>
+          </a:prstGeom>
+          <a:noFill/>
+        </p:spPr>
+        <p:txBody>
+          <a:bodyPr wrap="square" lIns="36576" rIns="36576" tIns="36576" bIns="36576" anchor="t">
+            <a:spAutoFit/>
+          </a:bodyPr>
+          <a:lstStyle/>
+          <a:p>
+            <a:pPr algn="l"/>
+            <a:r>
+              <a:rPr sz="2400" b="1">
                 <a:solidFill>
                   <a:srgbClr val="17212B"/>
                 </a:solidFill>
@@ -5813,23 +5813,23 @@
         </p:nvSpPr>
         <p:spPr>
           <a:xfrm>
-            <a:off x="530352" y="804672"/>
-            <a:ext cx="10789920" cy="201168"/>
-          </a:xfrm>
-          <a:prstGeom prst="rect">
-            <a:avLst/>
-          </a:prstGeom>
-          <a:noFill/>
-        </p:spPr>
-        <p:txBody>
-          <a:bodyPr wrap="square" lIns="36576" rIns="36576" tIns="36576" bIns="36576" anchor="t">
-            <a:spAutoFit/>
-          </a:bodyPr>
-          <a:lstStyle/>
-          <a:p>
-            <a:pPr algn="l"/>
-            <a:r>
-              <a:rPr sz="900" b="0">
+            <a:off x="530352" y="896112"/>
+            <a:ext cx="10789920" cy="164592"/>
+          </a:xfrm>
+          <a:prstGeom prst="rect">
+            <a:avLst/>
+          </a:prstGeom>
+          <a:noFill/>
+        </p:spPr>
+        <p:txBody>
+          <a:bodyPr wrap="square" lIns="36576" rIns="36576" tIns="36576" bIns="36576" anchor="t">
+            <a:spAutoFit/>
+          </a:bodyPr>
+          <a:lstStyle/>
+          <a:p>
+            <a:pPr algn="l"/>
+            <a:r>
+              <a:rPr sz="800" b="0">
                 <a:solidFill>
                   <a:srgbClr val="52616B"/>
                 </a:solidFill>
@@ -6397,7 +6397,7 @@
         </p:nvSpPr>
         <p:spPr>
           <a:xfrm>
-            <a:off x="530352" y="6437376"/>
+            <a:off x="530352" y="6236208"/>
             <a:ext cx="10607040" cy="164592"/>
           </a:xfrm>
           <a:prstGeom prst="rect">
@@ -6432,7 +6432,7 @@
         </p:nvSpPr>
         <p:spPr>
           <a:xfrm>
-            <a:off x="11356848" y="6409944"/>
+            <a:off x="11356848" y="6217920"/>
             <a:ext cx="320040" cy="182880"/>
           </a:xfrm>
           <a:prstGeom prst="rect">
@@ -6493,23 +6493,23 @@
         </p:nvSpPr>
         <p:spPr>
           <a:xfrm>
-            <a:off x="502920" y="256032"/>
-            <a:ext cx="10881360" cy="411480"/>
-          </a:xfrm>
-          <a:prstGeom prst="rect">
-            <a:avLst/>
-          </a:prstGeom>
-          <a:noFill/>
-        </p:spPr>
-        <p:txBody>
-          <a:bodyPr wrap="square" lIns="36576" rIns="36576" tIns="36576" bIns="36576" anchor="t">
-            <a:spAutoFit/>
-          </a:bodyPr>
-          <a:lstStyle/>
-          <a:p>
-            <a:pPr algn="l"/>
-            <a:r>
-              <a:rPr sz="2700" b="1">
+            <a:off x="502920" y="182880"/>
+            <a:ext cx="11109960" cy="640080"/>
+          </a:xfrm>
+          <a:prstGeom prst="rect">
+            <a:avLst/>
+          </a:prstGeom>
+          <a:noFill/>
+        </p:spPr>
+        <p:txBody>
+          <a:bodyPr wrap="square" lIns="36576" rIns="36576" tIns="36576" bIns="36576" anchor="t">
+            <a:spAutoFit/>
+          </a:bodyPr>
+          <a:lstStyle/>
+          <a:p>
+            <a:pPr algn="l"/>
+            <a:r>
+              <a:rPr sz="2400" b="1">
                 <a:solidFill>
                   <a:srgbClr val="17212B"/>
                 </a:solidFill>
@@ -6528,23 +6528,23 @@
         </p:nvSpPr>
         <p:spPr>
           <a:xfrm>
-            <a:off x="530352" y="804672"/>
-            <a:ext cx="10789920" cy="201168"/>
-          </a:xfrm>
-          <a:prstGeom prst="rect">
-            <a:avLst/>
-          </a:prstGeom>
-          <a:noFill/>
-        </p:spPr>
-        <p:txBody>
-          <a:bodyPr wrap="square" lIns="36576" rIns="36576" tIns="36576" bIns="36576" anchor="t">
-            <a:spAutoFit/>
-          </a:bodyPr>
-          <a:lstStyle/>
-          <a:p>
-            <a:pPr algn="l"/>
-            <a:r>
-              <a:rPr sz="900" b="0">
+            <a:off x="530352" y="896112"/>
+            <a:ext cx="10789920" cy="164592"/>
+          </a:xfrm>
+          <a:prstGeom prst="rect">
+            <a:avLst/>
+          </a:prstGeom>
+          <a:noFill/>
+        </p:spPr>
+        <p:txBody>
+          <a:bodyPr wrap="square" lIns="36576" rIns="36576" tIns="36576" bIns="36576" anchor="t">
+            <a:spAutoFit/>
+          </a:bodyPr>
+          <a:lstStyle/>
+          <a:p>
+            <a:pPr algn="l"/>
+            <a:r>
+              <a:rPr sz="800" b="0">
                 <a:solidFill>
                   <a:srgbClr val="52616B"/>
                 </a:solidFill>
@@ -7021,7 +7021,7 @@
         </p:nvSpPr>
         <p:spPr>
           <a:xfrm>
-            <a:off x="530352" y="6437376"/>
+            <a:off x="530352" y="6236208"/>
             <a:ext cx="10607040" cy="164592"/>
           </a:xfrm>
           <a:prstGeom prst="rect">
@@ -7056,7 +7056,7 @@
         </p:nvSpPr>
         <p:spPr>
           <a:xfrm>
-            <a:off x="11356848" y="6409944"/>
+            <a:off x="11356848" y="6217920"/>
             <a:ext cx="320040" cy="182880"/>
           </a:xfrm>
           <a:prstGeom prst="rect">
@@ -7117,23 +7117,23 @@
         </p:nvSpPr>
         <p:spPr>
           <a:xfrm>
-            <a:off x="502920" y="256032"/>
-            <a:ext cx="10881360" cy="411480"/>
-          </a:xfrm>
-          <a:prstGeom prst="rect">
-            <a:avLst/>
-          </a:prstGeom>
-          <a:noFill/>
-        </p:spPr>
-        <p:txBody>
-          <a:bodyPr wrap="square" lIns="36576" rIns="36576" tIns="36576" bIns="36576" anchor="t">
-            <a:spAutoFit/>
-          </a:bodyPr>
-          <a:lstStyle/>
-          <a:p>
-            <a:pPr algn="l"/>
-            <a:r>
-              <a:rPr sz="2700" b="1">
+            <a:off x="502920" y="182880"/>
+            <a:ext cx="11109960" cy="640080"/>
+          </a:xfrm>
+          <a:prstGeom prst="rect">
+            <a:avLst/>
+          </a:prstGeom>
+          <a:noFill/>
+        </p:spPr>
+        <p:txBody>
+          <a:bodyPr wrap="square" lIns="36576" rIns="36576" tIns="36576" bIns="36576" anchor="t">
+            <a:spAutoFit/>
+          </a:bodyPr>
+          <a:lstStyle/>
+          <a:p>
+            <a:pPr algn="l"/>
+            <a:r>
+              <a:rPr sz="2400" b="1">
                 <a:solidFill>
                   <a:srgbClr val="17212B"/>
                 </a:solidFill>
@@ -7152,23 +7152,23 @@
         </p:nvSpPr>
         <p:spPr>
           <a:xfrm>
-            <a:off x="530352" y="804672"/>
-            <a:ext cx="10789920" cy="201168"/>
-          </a:xfrm>
-          <a:prstGeom prst="rect">
-            <a:avLst/>
-          </a:prstGeom>
-          <a:noFill/>
-        </p:spPr>
-        <p:txBody>
-          <a:bodyPr wrap="square" lIns="36576" rIns="36576" tIns="36576" bIns="36576" anchor="t">
-            <a:spAutoFit/>
-          </a:bodyPr>
-          <a:lstStyle/>
-          <a:p>
-            <a:pPr algn="l"/>
-            <a:r>
-              <a:rPr sz="900" b="0">
+            <a:off x="530352" y="896112"/>
+            <a:ext cx="10789920" cy="164592"/>
+          </a:xfrm>
+          <a:prstGeom prst="rect">
+            <a:avLst/>
+          </a:prstGeom>
+          <a:noFill/>
+        </p:spPr>
+        <p:txBody>
+          <a:bodyPr wrap="square" lIns="36576" rIns="36576" tIns="36576" bIns="36576" anchor="t">
+            <a:spAutoFit/>
+          </a:bodyPr>
+          <a:lstStyle/>
+          <a:p>
+            <a:pPr algn="l"/>
+            <a:r>
+              <a:rPr sz="800" b="0">
                 <a:solidFill>
                   <a:srgbClr val="52616B"/>
                 </a:solidFill>
@@ -8247,7 +8247,7 @@
         </p:nvSpPr>
         <p:spPr>
           <a:xfrm>
-            <a:off x="530352" y="6437376"/>
+            <a:off x="530352" y="6236208"/>
             <a:ext cx="10607040" cy="164592"/>
           </a:xfrm>
           <a:prstGeom prst="rect">
@@ -8282,7 +8282,7 @@
         </p:nvSpPr>
         <p:spPr>
           <a:xfrm>
-            <a:off x="11356848" y="6409944"/>
+            <a:off x="11356848" y="6217920"/>
             <a:ext cx="320040" cy="182880"/>
           </a:xfrm>
           <a:prstGeom prst="rect">
@@ -8343,23 +8343,23 @@
         </p:nvSpPr>
         <p:spPr>
           <a:xfrm>
-            <a:off x="502920" y="256032"/>
-            <a:ext cx="10881360" cy="411480"/>
-          </a:xfrm>
-          <a:prstGeom prst="rect">
-            <a:avLst/>
-          </a:prstGeom>
-          <a:noFill/>
-        </p:spPr>
-        <p:txBody>
-          <a:bodyPr wrap="square" lIns="36576" rIns="36576" tIns="36576" bIns="36576" anchor="t">
-            <a:spAutoFit/>
-          </a:bodyPr>
-          <a:lstStyle/>
-          <a:p>
-            <a:pPr algn="l"/>
-            <a:r>
-              <a:rPr sz="2200" b="1">
+            <a:off x="502920" y="182880"/>
+            <a:ext cx="11109960" cy="640080"/>
+          </a:xfrm>
+          <a:prstGeom prst="rect">
+            <a:avLst/>
+          </a:prstGeom>
+          <a:noFill/>
+        </p:spPr>
+        <p:txBody>
+          <a:bodyPr wrap="square" lIns="36576" rIns="36576" tIns="36576" bIns="36576" anchor="t">
+            <a:spAutoFit/>
+          </a:bodyPr>
+          <a:lstStyle/>
+          <a:p>
+            <a:pPr algn="l"/>
+            <a:r>
+              <a:rPr sz="2400" b="1">
                 <a:solidFill>
                   <a:srgbClr val="17212B"/>
                 </a:solidFill>
@@ -8378,23 +8378,23 @@
         </p:nvSpPr>
         <p:spPr>
           <a:xfrm>
-            <a:off x="530352" y="804672"/>
-            <a:ext cx="10789920" cy="201168"/>
-          </a:xfrm>
-          <a:prstGeom prst="rect">
-            <a:avLst/>
-          </a:prstGeom>
-          <a:noFill/>
-        </p:spPr>
-        <p:txBody>
-          <a:bodyPr wrap="square" lIns="36576" rIns="36576" tIns="36576" bIns="36576" anchor="t">
-            <a:spAutoFit/>
-          </a:bodyPr>
-          <a:lstStyle/>
-          <a:p>
-            <a:pPr algn="l"/>
-            <a:r>
-              <a:rPr sz="900" b="0">
+            <a:off x="530352" y="896112"/>
+            <a:ext cx="10789920" cy="164592"/>
+          </a:xfrm>
+          <a:prstGeom prst="rect">
+            <a:avLst/>
+          </a:prstGeom>
+          <a:noFill/>
+        </p:spPr>
+        <p:txBody>
+          <a:bodyPr wrap="square" lIns="36576" rIns="36576" tIns="36576" bIns="36576" anchor="t">
+            <a:spAutoFit/>
+          </a:bodyPr>
+          <a:lstStyle/>
+          <a:p>
+            <a:pPr algn="l"/>
+            <a:r>
+              <a:rPr sz="800" b="0">
                 <a:solidFill>
                   <a:srgbClr val="52616B"/>
                 </a:solidFill>
@@ -8982,8 +8982,8 @@
         </p:nvSpPr>
         <p:spPr>
           <a:xfrm>
-            <a:off x="749808" y="4069080"/>
-            <a:ext cx="5212080" cy="960120"/>
+            <a:off x="749808" y="3886200"/>
+            <a:ext cx="5212080" cy="1188720"/>
           </a:xfrm>
           <a:prstGeom prst="roundRect">
             <a:avLst/>
@@ -9027,8 +9027,8 @@
         </p:nvSpPr>
         <p:spPr>
           <a:xfrm>
-            <a:off x="749808" y="4069080"/>
-            <a:ext cx="91440" cy="960120"/>
+            <a:off x="749808" y="3886200"/>
+            <a:ext cx="91440" cy="1188720"/>
           </a:xfrm>
           <a:prstGeom prst="rect">
             <a:avLst/>
@@ -9072,7 +9072,7 @@
         </p:nvSpPr>
         <p:spPr>
           <a:xfrm>
-            <a:off x="950976" y="4197096"/>
+            <a:off x="950976" y="4014215"/>
             <a:ext cx="4901184" cy="237744"/>
           </a:xfrm>
           <a:prstGeom prst="rect">
@@ -9107,23 +9107,23 @@
         </p:nvSpPr>
         <p:spPr>
           <a:xfrm>
-            <a:off x="950976" y="4507992"/>
-            <a:ext cx="4901184" cy="429768"/>
-          </a:xfrm>
-          <a:prstGeom prst="rect">
-            <a:avLst/>
-          </a:prstGeom>
-          <a:noFill/>
-        </p:spPr>
-        <p:txBody>
-          <a:bodyPr wrap="square" lIns="36576" rIns="36576" tIns="36576" bIns="36576" anchor="t">
-            <a:spAutoFit/>
-          </a:bodyPr>
-          <a:lstStyle/>
-          <a:p>
-            <a:pPr algn="l"/>
-            <a:r>
-              <a:rPr sz="1000" b="0">
+            <a:off x="950976" y="4325112"/>
+            <a:ext cx="4901184" cy="658368"/>
+          </a:xfrm>
+          <a:prstGeom prst="rect">
+            <a:avLst/>
+          </a:prstGeom>
+          <a:noFill/>
+        </p:spPr>
+        <p:txBody>
+          <a:bodyPr wrap="square" lIns="36576" rIns="36576" tIns="36576" bIns="36576" anchor="t">
+            <a:spAutoFit/>
+          </a:bodyPr>
+          <a:lstStyle/>
+          <a:p>
+            <a:pPr algn="l"/>
+            <a:r>
+              <a:rPr sz="1100" b="0">
                 <a:solidFill>
                   <a:srgbClr val="52616B"/>
                 </a:solidFill>
@@ -9142,8 +9142,8 @@
         </p:nvSpPr>
         <p:spPr>
           <a:xfrm>
-            <a:off x="6263640" y="4069080"/>
-            <a:ext cx="5212080" cy="960120"/>
+            <a:off x="6263640" y="3886200"/>
+            <a:ext cx="5212080" cy="1188720"/>
           </a:xfrm>
           <a:prstGeom prst="roundRect">
             <a:avLst/>
@@ -9187,8 +9187,8 @@
         </p:nvSpPr>
         <p:spPr>
           <a:xfrm>
-            <a:off x="6263640" y="4069080"/>
-            <a:ext cx="91440" cy="960120"/>
+            <a:off x="6263640" y="3886200"/>
+            <a:ext cx="91440" cy="1188720"/>
           </a:xfrm>
           <a:prstGeom prst="rect">
             <a:avLst/>
@@ -9232,7 +9232,7 @@
         </p:nvSpPr>
         <p:spPr>
           <a:xfrm>
-            <a:off x="6464807" y="4197096"/>
+            <a:off x="6464807" y="4014215"/>
             <a:ext cx="4901184" cy="237744"/>
           </a:xfrm>
           <a:prstGeom prst="rect">
@@ -9267,8 +9267,8 @@
         </p:nvSpPr>
         <p:spPr>
           <a:xfrm>
-            <a:off x="6464807" y="4507992"/>
-            <a:ext cx="4901184" cy="429768"/>
+            <a:off x="6464807" y="4325112"/>
+            <a:ext cx="4901184" cy="658368"/>
           </a:xfrm>
           <a:prstGeom prst="rect">
             <a:avLst/>
@@ -9302,7 +9302,7 @@
         </p:nvSpPr>
         <p:spPr>
           <a:xfrm>
-            <a:off x="530352" y="6437376"/>
+            <a:off x="530352" y="6236208"/>
             <a:ext cx="10607040" cy="164592"/>
           </a:xfrm>
           <a:prstGeom prst="rect">
@@ -9337,7 +9337,7 @@
         </p:nvSpPr>
         <p:spPr>
           <a:xfrm>
-            <a:off x="11356848" y="6409944"/>
+            <a:off x="11356848" y="6217920"/>
             <a:ext cx="320040" cy="182880"/>
           </a:xfrm>
           <a:prstGeom prst="rect">
@@ -9398,23 +9398,23 @@
         </p:nvSpPr>
         <p:spPr>
           <a:xfrm>
-            <a:off x="502920" y="256032"/>
-            <a:ext cx="10881360" cy="411480"/>
-          </a:xfrm>
-          <a:prstGeom prst="rect">
-            <a:avLst/>
-          </a:prstGeom>
-          <a:noFill/>
-        </p:spPr>
-        <p:txBody>
-          <a:bodyPr wrap="square" lIns="36576" rIns="36576" tIns="36576" bIns="36576" anchor="t">
-            <a:spAutoFit/>
-          </a:bodyPr>
-          <a:lstStyle/>
-          <a:p>
-            <a:pPr algn="l"/>
-            <a:r>
-              <a:rPr sz="2700" b="1">
+            <a:off x="502920" y="182880"/>
+            <a:ext cx="11109960" cy="640080"/>
+          </a:xfrm>
+          <a:prstGeom prst="rect">
+            <a:avLst/>
+          </a:prstGeom>
+          <a:noFill/>
+        </p:spPr>
+        <p:txBody>
+          <a:bodyPr wrap="square" lIns="36576" rIns="36576" tIns="36576" bIns="36576" anchor="t">
+            <a:spAutoFit/>
+          </a:bodyPr>
+          <a:lstStyle/>
+          <a:p>
+            <a:pPr algn="l"/>
+            <a:r>
+              <a:rPr sz="2400" b="1">
                 <a:solidFill>
                   <a:srgbClr val="17212B"/>
                 </a:solidFill>
@@ -9433,23 +9433,23 @@
         </p:nvSpPr>
         <p:spPr>
           <a:xfrm>
-            <a:off x="530352" y="804672"/>
-            <a:ext cx="10789920" cy="201168"/>
-          </a:xfrm>
-          <a:prstGeom prst="rect">
-            <a:avLst/>
-          </a:prstGeom>
-          <a:noFill/>
-        </p:spPr>
-        <p:txBody>
-          <a:bodyPr wrap="square" lIns="36576" rIns="36576" tIns="36576" bIns="36576" anchor="t">
-            <a:spAutoFit/>
-          </a:bodyPr>
-          <a:lstStyle/>
-          <a:p>
-            <a:pPr algn="l"/>
-            <a:r>
-              <a:rPr sz="900" b="0">
+            <a:off x="530352" y="896112"/>
+            <a:ext cx="10789920" cy="164592"/>
+          </a:xfrm>
+          <a:prstGeom prst="rect">
+            <a:avLst/>
+          </a:prstGeom>
+          <a:noFill/>
+        </p:spPr>
+        <p:txBody>
+          <a:bodyPr wrap="square" lIns="36576" rIns="36576" tIns="36576" bIns="36576" anchor="t">
+            <a:spAutoFit/>
+          </a:bodyPr>
+          <a:lstStyle/>
+          <a:p>
+            <a:pPr algn="l"/>
+            <a:r>
+              <a:rPr sz="800" b="0">
                 <a:solidFill>
                   <a:srgbClr val="52616B"/>
                 </a:solidFill>
@@ -10044,8 +10044,8 @@
         </p:nvSpPr>
         <p:spPr>
           <a:xfrm>
-            <a:off x="868680" y="5074920"/>
-            <a:ext cx="10424160" cy="685800"/>
+            <a:off x="868680" y="4965192"/>
+            <a:ext cx="10424160" cy="822960"/>
           </a:xfrm>
           <a:prstGeom prst="roundRect">
             <a:avLst/>
@@ -10089,8 +10089,8 @@
         </p:nvSpPr>
         <p:spPr>
           <a:xfrm>
-            <a:off x="868680" y="5074920"/>
-            <a:ext cx="91440" cy="685800"/>
+            <a:off x="868680" y="4965192"/>
+            <a:ext cx="91440" cy="822960"/>
           </a:xfrm>
           <a:prstGeom prst="rect">
             <a:avLst/>
@@ -10134,7 +10134,7 @@
         </p:nvSpPr>
         <p:spPr>
           <a:xfrm>
-            <a:off x="1069848" y="5202936"/>
+            <a:off x="1069848" y="5093207"/>
             <a:ext cx="10113264" cy="237744"/>
           </a:xfrm>
           <a:prstGeom prst="rect">
@@ -10169,8 +10169,8 @@
         </p:nvSpPr>
         <p:spPr>
           <a:xfrm>
-            <a:off x="1069848" y="5513831"/>
-            <a:ext cx="10113264" cy="155448"/>
+            <a:off x="1069848" y="5404104"/>
+            <a:ext cx="10113264" cy="292608"/>
           </a:xfrm>
           <a:prstGeom prst="rect">
             <a:avLst/>
@@ -10204,7 +10204,7 @@
         </p:nvSpPr>
         <p:spPr>
           <a:xfrm>
-            <a:off x="11356848" y="6409944"/>
+            <a:off x="11356848" y="6217920"/>
             <a:ext cx="320040" cy="182880"/>
           </a:xfrm>
           <a:prstGeom prst="rect">
@@ -10265,23 +10265,23 @@
         </p:nvSpPr>
         <p:spPr>
           <a:xfrm>
-            <a:off x="502920" y="256032"/>
-            <a:ext cx="10881360" cy="411480"/>
-          </a:xfrm>
-          <a:prstGeom prst="rect">
-            <a:avLst/>
-          </a:prstGeom>
-          <a:noFill/>
-        </p:spPr>
-        <p:txBody>
-          <a:bodyPr wrap="square" lIns="36576" rIns="36576" tIns="36576" bIns="36576" anchor="t">
-            <a:spAutoFit/>
-          </a:bodyPr>
-          <a:lstStyle/>
-          <a:p>
-            <a:pPr algn="l"/>
-            <a:r>
-              <a:rPr sz="2700" b="1">
+            <a:off x="502920" y="182880"/>
+            <a:ext cx="11109960" cy="640080"/>
+          </a:xfrm>
+          <a:prstGeom prst="rect">
+            <a:avLst/>
+          </a:prstGeom>
+          <a:noFill/>
+        </p:spPr>
+        <p:txBody>
+          <a:bodyPr wrap="square" lIns="36576" rIns="36576" tIns="36576" bIns="36576" anchor="t">
+            <a:spAutoFit/>
+          </a:bodyPr>
+          <a:lstStyle/>
+          <a:p>
+            <a:pPr algn="l"/>
+            <a:r>
+              <a:rPr sz="2400" b="1">
                 <a:solidFill>
                   <a:srgbClr val="FFFFFF"/>
                 </a:solidFill>
@@ -10300,23 +10300,23 @@
         </p:nvSpPr>
         <p:spPr>
           <a:xfrm>
-            <a:off x="530352" y="804672"/>
-            <a:ext cx="10789920" cy="201168"/>
-          </a:xfrm>
-          <a:prstGeom prst="rect">
-            <a:avLst/>
-          </a:prstGeom>
-          <a:noFill/>
-        </p:spPr>
-        <p:txBody>
-          <a:bodyPr wrap="square" lIns="36576" rIns="36576" tIns="36576" bIns="36576" anchor="t">
-            <a:spAutoFit/>
-          </a:bodyPr>
-          <a:lstStyle/>
-          <a:p>
-            <a:pPr algn="l"/>
-            <a:r>
-              <a:rPr sz="900" b="0">
+            <a:off x="530352" y="896112"/>
+            <a:ext cx="10789920" cy="164592"/>
+          </a:xfrm>
+          <a:prstGeom prst="rect">
+            <a:avLst/>
+          </a:prstGeom>
+          <a:noFill/>
+        </p:spPr>
+        <p:txBody>
+          <a:bodyPr wrap="square" lIns="36576" rIns="36576" tIns="36576" bIns="36576" anchor="t">
+            <a:spAutoFit/>
+          </a:bodyPr>
+          <a:lstStyle/>
+          <a:p>
+            <a:pPr algn="l"/>
+            <a:r>
+              <a:rPr sz="800" b="0">
                 <a:solidFill>
                   <a:srgbClr val="B7C8C4"/>
                 </a:solidFill>
@@ -10957,7 +10957,7 @@
                 </a:solidFill>
                 <a:latin typeface="Aptos"/>
               </a:rPr>
-              <a:t>正式入口：README -&gt; Survey -&gt; 10 篇 Paper -&gt; Figure inventory -&gt; PPT</a:t>
+              <a:t>完整图文精读、代码 commit、图清单与 QA：Custom Attention README -&gt; Survey -&gt; Paper -&gt; Asset</a:t>
             </a:r>
           </a:p>
         </p:txBody>
@@ -10970,7 +10970,7 @@
         </p:nvSpPr>
         <p:spPr>
           <a:xfrm>
-            <a:off x="11356848" y="6409944"/>
+            <a:off x="11356848" y="6217920"/>
             <a:ext cx="320040" cy="182880"/>
           </a:xfrm>
           <a:prstGeom prst="rect">
@@ -11031,23 +11031,23 @@
         </p:nvSpPr>
         <p:spPr>
           <a:xfrm>
-            <a:off x="502920" y="256032"/>
-            <a:ext cx="10881360" cy="411480"/>
-          </a:xfrm>
-          <a:prstGeom prst="rect">
-            <a:avLst/>
-          </a:prstGeom>
-          <a:noFill/>
-        </p:spPr>
-        <p:txBody>
-          <a:bodyPr wrap="square" lIns="36576" rIns="36576" tIns="36576" bIns="36576" anchor="t">
-            <a:spAutoFit/>
-          </a:bodyPr>
-          <a:lstStyle/>
-          <a:p>
-            <a:pPr algn="l"/>
-            <a:r>
-              <a:rPr sz="2700" b="1">
+            <a:off x="502920" y="182880"/>
+            <a:ext cx="11109960" cy="640080"/>
+          </a:xfrm>
+          <a:prstGeom prst="rect">
+            <a:avLst/>
+          </a:prstGeom>
+          <a:noFill/>
+        </p:spPr>
+        <p:txBody>
+          <a:bodyPr wrap="square" lIns="36576" rIns="36576" tIns="36576" bIns="36576" anchor="t">
+            <a:spAutoFit/>
+          </a:bodyPr>
+          <a:lstStyle/>
+          <a:p>
+            <a:pPr algn="l"/>
+            <a:r>
+              <a:rPr sz="2400" b="1">
                 <a:solidFill>
                   <a:srgbClr val="17212B"/>
                 </a:solidFill>
@@ -11066,23 +11066,23 @@
         </p:nvSpPr>
         <p:spPr>
           <a:xfrm>
-            <a:off x="530352" y="804672"/>
-            <a:ext cx="10789920" cy="201168"/>
-          </a:xfrm>
-          <a:prstGeom prst="rect">
-            <a:avLst/>
-          </a:prstGeom>
-          <a:noFill/>
-        </p:spPr>
-        <p:txBody>
-          <a:bodyPr wrap="square" lIns="36576" rIns="36576" tIns="36576" bIns="36576" anchor="t">
-            <a:spAutoFit/>
-          </a:bodyPr>
-          <a:lstStyle/>
-          <a:p>
-            <a:pPr algn="l"/>
-            <a:r>
-              <a:rPr sz="900" b="0">
+            <a:off x="530352" y="896112"/>
+            <a:ext cx="10789920" cy="164592"/>
+          </a:xfrm>
+          <a:prstGeom prst="rect">
+            <a:avLst/>
+          </a:prstGeom>
+          <a:noFill/>
+        </p:spPr>
+        <p:txBody>
+          <a:bodyPr wrap="square" lIns="36576" rIns="36576" tIns="36576" bIns="36576" anchor="t">
+            <a:spAutoFit/>
+          </a:bodyPr>
+          <a:lstStyle/>
+          <a:p>
+            <a:pPr algn="l"/>
+            <a:r>
+              <a:rPr sz="800" b="0">
                 <a:solidFill>
                   <a:srgbClr val="52616B"/>
                 </a:solidFill>
@@ -12041,7 +12041,7 @@
         </p:nvSpPr>
         <p:spPr>
           <a:xfrm>
-            <a:off x="11356848" y="6409944"/>
+            <a:off x="11356848" y="6217920"/>
             <a:ext cx="320040" cy="182880"/>
           </a:xfrm>
           <a:prstGeom prst="rect">
@@ -12102,23 +12102,23 @@
         </p:nvSpPr>
         <p:spPr>
           <a:xfrm>
-            <a:off x="502920" y="256032"/>
-            <a:ext cx="10881360" cy="411480"/>
-          </a:xfrm>
-          <a:prstGeom prst="rect">
-            <a:avLst/>
-          </a:prstGeom>
-          <a:noFill/>
-        </p:spPr>
-        <p:txBody>
-          <a:bodyPr wrap="square" lIns="36576" rIns="36576" tIns="36576" bIns="36576" anchor="t">
-            <a:spAutoFit/>
-          </a:bodyPr>
-          <a:lstStyle/>
-          <a:p>
-            <a:pPr algn="l"/>
-            <a:r>
-              <a:rPr sz="2700" b="1">
+            <a:off x="502920" y="182880"/>
+            <a:ext cx="11109960" cy="640080"/>
+          </a:xfrm>
+          <a:prstGeom prst="rect">
+            <a:avLst/>
+          </a:prstGeom>
+          <a:noFill/>
+        </p:spPr>
+        <p:txBody>
+          <a:bodyPr wrap="square" lIns="36576" rIns="36576" tIns="36576" bIns="36576" anchor="t">
+            <a:spAutoFit/>
+          </a:bodyPr>
+          <a:lstStyle/>
+          <a:p>
+            <a:pPr algn="l"/>
+            <a:r>
+              <a:rPr sz="2400" b="1">
                 <a:solidFill>
                   <a:srgbClr val="17212B"/>
                 </a:solidFill>
@@ -12137,23 +12137,23 @@
         </p:nvSpPr>
         <p:spPr>
           <a:xfrm>
-            <a:off x="530352" y="804672"/>
-            <a:ext cx="10789920" cy="201168"/>
-          </a:xfrm>
-          <a:prstGeom prst="rect">
-            <a:avLst/>
-          </a:prstGeom>
-          <a:noFill/>
-        </p:spPr>
-        <p:txBody>
-          <a:bodyPr wrap="square" lIns="36576" rIns="36576" tIns="36576" bIns="36576" anchor="t">
-            <a:spAutoFit/>
-          </a:bodyPr>
-          <a:lstStyle/>
-          <a:p>
-            <a:pPr algn="l"/>
-            <a:r>
-              <a:rPr sz="900" b="0">
+            <a:off x="530352" y="896112"/>
+            <a:ext cx="10789920" cy="164592"/>
+          </a:xfrm>
+          <a:prstGeom prst="rect">
+            <a:avLst/>
+          </a:prstGeom>
+          <a:noFill/>
+        </p:spPr>
+        <p:txBody>
+          <a:bodyPr wrap="square" lIns="36576" rIns="36576" tIns="36576" bIns="36576" anchor="t">
+            <a:spAutoFit/>
+          </a:bodyPr>
+          <a:lstStyle/>
+          <a:p>
+            <a:pPr algn="l"/>
+            <a:r>
+              <a:rPr sz="800" b="0">
                 <a:solidFill>
                   <a:srgbClr val="52616B"/>
                 </a:solidFill>
@@ -13127,7 +13127,7 @@
         </p:nvSpPr>
         <p:spPr>
           <a:xfrm>
-            <a:off x="11356848" y="6409944"/>
+            <a:off x="11356848" y="6217920"/>
             <a:ext cx="320040" cy="182880"/>
           </a:xfrm>
           <a:prstGeom prst="rect">
@@ -13188,29 +13188,29 @@
         </p:nvSpPr>
         <p:spPr>
           <a:xfrm>
-            <a:off x="502920" y="256032"/>
-            <a:ext cx="10881360" cy="411480"/>
-          </a:xfrm>
-          <a:prstGeom prst="rect">
-            <a:avLst/>
-          </a:prstGeom>
-          <a:noFill/>
-        </p:spPr>
-        <p:txBody>
-          <a:bodyPr wrap="square" lIns="36576" rIns="36576" tIns="36576" bIns="36576" anchor="t">
-            <a:spAutoFit/>
-          </a:bodyPr>
-          <a:lstStyle/>
-          <a:p>
-            <a:pPr algn="l"/>
-            <a:r>
-              <a:rPr sz="2700" b="1">
+            <a:off x="502920" y="182880"/>
+            <a:ext cx="11109960" cy="640080"/>
+          </a:xfrm>
+          <a:prstGeom prst="rect">
+            <a:avLst/>
+          </a:prstGeom>
+          <a:noFill/>
+        </p:spPr>
+        <p:txBody>
+          <a:bodyPr wrap="square" lIns="36576" rIns="36576" tIns="36576" bIns="36576" anchor="t">
+            <a:spAutoFit/>
+          </a:bodyPr>
+          <a:lstStyle/>
+          <a:p>
+            <a:pPr algn="l"/>
+            <a:r>
+              <a:rPr sz="2400" b="1">
                 <a:solidFill>
                   <a:srgbClr val="17212B"/>
                 </a:solidFill>
                 <a:latin typeface="Aptos Display"/>
               </a:rPr>
-              <a:t>理解侧：FlexAttention VLM 的高分辨率 token selection</a:t>
+              <a:t>理解侧：FlexAttention VLM 只让 query 读取被选中的高分辨率细节</a:t>
             </a:r>
           </a:p>
         </p:txBody>
@@ -13223,23 +13223,23 @@
         </p:nvSpPr>
         <p:spPr>
           <a:xfrm>
-            <a:off x="530352" y="804672"/>
-            <a:ext cx="10789920" cy="201168"/>
-          </a:xfrm>
-          <a:prstGeom prst="rect">
-            <a:avLst/>
-          </a:prstGeom>
-          <a:noFill/>
-        </p:spPr>
-        <p:txBody>
-          <a:bodyPr wrap="square" lIns="36576" rIns="36576" tIns="36576" bIns="36576" anchor="t">
-            <a:spAutoFit/>
-          </a:bodyPr>
-          <a:lstStyle/>
-          <a:p>
-            <a:pPr algn="l"/>
-            <a:r>
-              <a:rPr sz="900" b="0">
+            <a:off x="530352" y="896112"/>
+            <a:ext cx="10789920" cy="164592"/>
+          </a:xfrm>
+          <a:prstGeom prst="rect">
+            <a:avLst/>
+          </a:prstGeom>
+          <a:noFill/>
+        </p:spPr>
+        <p:txBody>
+          <a:bodyPr wrap="square" lIns="36576" rIns="36576" tIns="36576" bIns="36576" anchor="t">
+            <a:spAutoFit/>
+          </a:bodyPr>
+          <a:lstStyle/>
+          <a:p>
+            <a:pPr algn="l"/>
+            <a:r>
+              <a:rPr sz="800" b="0">
                 <a:solidFill>
                   <a:srgbClr val="52616B"/>
                 </a:solidFill>
@@ -13474,7 +13474,7 @@
                 </a:solidFill>
                 <a:latin typeface="Aptos"/>
               </a:rPr>
-              <a:t>所有 high-resolution patch 与文本一起全注意力，分辨率升高时 decoder 成本失控。</a:t>
+              <a:t>全量 high-resolution patch 进入 decoder 会产生 quadratic query/key work；只降采样又丢小文字和小目标。</a:t>
             </a:r>
           </a:p>
         </p:txBody>
@@ -13634,7 +13634,7 @@
                 </a:solidFill>
                 <a:latin typeface="Aptos"/>
               </a:rPr>
-              <a:t>低分辨率/文本先给全局语义；attention map 选出高分辨率区域 token，再进 hierarchical self-attention。</a:t>
+              <a:t>低分辨率与文本保留 N-token residual stream；上一层 attention map 选择约 10% high-resolution features，仅作为额外 K/V。</a:t>
             </a:r>
           </a:p>
         </p:txBody>
@@ -13794,7 +13794,7 @@
                 </a:solidFill>
                 <a:latin typeface="Aptos"/>
               </a:rPr>
-              <a:t>selected indices -&gt; gather high-res feature -&gt; compact attention。具体 CUDA backend 本次未逐行核验，不能把方法名等同 PyTorch FlexAttention。</a:t>
+              <a:t>数学对象是 N x (N+M) rectangular attention。compact/varlen 是实现建议；论文未声称 PyTorch FlexAttention 或特定 sparse CUDA backend。V100 上 TextVQA 总时间比 HD/XAttn 低 13%/24%。</a:t>
             </a:r>
           </a:p>
         </p:txBody>
@@ -13807,7 +13807,7 @@
         </p:nvSpPr>
         <p:spPr>
           <a:xfrm>
-            <a:off x="530352" y="6437376"/>
+            <a:off x="530352" y="6236208"/>
             <a:ext cx="10607040" cy="164592"/>
           </a:xfrm>
           <a:prstGeom prst="rect">
@@ -13829,7 +13829,7 @@
                 </a:solidFill>
                 <a:latin typeface="Aptos"/>
               </a:rPr>
-              <a:t>Paper Fig.2, arXiv:2407.20228; official UMass repository</a:t>
+              <a:t>FlexAttention Fig.2 &amp; Table 5; ECCV 2024; code f814be5</a:t>
             </a:r>
           </a:p>
         </p:txBody>
@@ -13842,7 +13842,7 @@
         </p:nvSpPr>
         <p:spPr>
           <a:xfrm>
-            <a:off x="11356848" y="6409944"/>
+            <a:off x="11356848" y="6217920"/>
             <a:ext cx="320040" cy="182880"/>
           </a:xfrm>
           <a:prstGeom prst="rect">
@@ -13903,29 +13903,29 @@
         </p:nvSpPr>
         <p:spPr>
           <a:xfrm>
-            <a:off x="502920" y="256032"/>
-            <a:ext cx="10881360" cy="411480"/>
-          </a:xfrm>
-          <a:prstGeom prst="rect">
-            <a:avLst/>
-          </a:prstGeom>
-          <a:noFill/>
-        </p:spPr>
-        <p:txBody>
-          <a:bodyPr wrap="square" lIns="36576" rIns="36576" tIns="36576" bIns="36576" anchor="t">
-            <a:spAutoFit/>
-          </a:bodyPr>
-          <a:lstStyle/>
-          <a:p>
-            <a:pPr algn="l"/>
-            <a:r>
-              <a:rPr sz="2700" b="1">
+            <a:off x="502920" y="182880"/>
+            <a:ext cx="11109960" cy="640080"/>
+          </a:xfrm>
+          <a:prstGeom prst="rect">
+            <a:avLst/>
+          </a:prstGeom>
+          <a:noFill/>
+        </p:spPr>
+        <p:txBody>
+          <a:bodyPr wrap="square" lIns="36576" rIns="36576" tIns="36576" bIns="36576" anchor="t">
+            <a:spAutoFit/>
+          </a:bodyPr>
+          <a:lstStyle/>
+          <a:p>
+            <a:pPr algn="l"/>
+            <a:r>
+              <a:rPr sz="2400" b="1">
                 <a:solidFill>
                   <a:srgbClr val="17212B"/>
                 </a:solidFill>
                 <a:latin typeface="Aptos Display"/>
               </a:rPr>
-              <a:t>统一模型：Cosmos 3 将混合 mask 降低为两个 varlen 调用</a:t>
+              <a:t>统一模型：Cosmos 3 先拆语义，再复用两类 varlen attention</a:t>
             </a:r>
           </a:p>
         </p:txBody>
@@ -13938,23 +13938,23 @@
         </p:nvSpPr>
         <p:spPr>
           <a:xfrm>
-            <a:off x="530352" y="804672"/>
-            <a:ext cx="10789920" cy="201168"/>
-          </a:xfrm>
-          <a:prstGeom prst="rect">
-            <a:avLst/>
-          </a:prstGeom>
-          <a:noFill/>
-        </p:spPr>
-        <p:txBody>
-          <a:bodyPr wrap="square" lIns="36576" rIns="36576" tIns="36576" bIns="36576" anchor="t">
-            <a:spAutoFit/>
-          </a:bodyPr>
-          <a:lstStyle/>
-          <a:p>
-            <a:pPr algn="l"/>
-            <a:r>
-              <a:rPr sz="900" b="0">
+            <a:off x="530352" y="896112"/>
+            <a:ext cx="10789920" cy="164592"/>
+          </a:xfrm>
+          <a:prstGeom prst="rect">
+            <a:avLst/>
+          </a:prstGeom>
+          <a:noFill/>
+        </p:spPr>
+        <p:txBody>
+          <a:bodyPr wrap="square" lIns="36576" rIns="36576" tIns="36576" bIns="36576" anchor="t">
+            <a:spAutoFit/>
+          </a:bodyPr>
+          <a:lstStyle/>
+          <a:p>
+            <a:pPr algn="l"/>
+            <a:r>
+              <a:rPr sz="800" b="0">
                 <a:solidFill>
                   <a:srgbClr val="52616B"/>
                 </a:solidFill>
@@ -14012,7 +14012,7 @@
       </p:sp>
       <p:pic>
         <p:nvPicPr>
-          <p:cNvPr id="5" name="Picture 4" descr="two_way_attention_infra.png"/>
+          <p:cNvPr id="5" name="Picture 4" descr="two-way-attention-infra.png"/>
           <p:cNvPicPr>
             <a:picLocks noChangeAspect="1"/>
           </p:cNvPicPr>
@@ -14189,7 +14189,7 @@
                 </a:solidFill>
                 <a:latin typeface="Aptos"/>
               </a:rPr>
-              <a:t>reasoner 必须 causal 且不受 noisy generator 污染；generator 又必须读同样本 reasoner + 自身 token。</a:t>
+              <a:t>reasoner 必须 causal 且不能读取 noisy generator；generator 又要读取同样本 AR 条件与全部 DM tokens。</a:t>
             </a:r>
           </a:p>
         </p:txBody>
@@ -14349,7 +14349,7 @@
                 </a:solidFill>
                 <a:latin typeface="Aptos"/>
               </a:rPr>
-              <a:t>reasoner: causal self-attention；generator: bidirectional attention over [reasoner, generator]。按 sample 打包，避免跨样本 read。</a:t>
+              <a:t>同一 packed sample lower 为 AR causal call 与 DM full rectangular call；跨样本用 offsets 隔离。</a:t>
             </a:r>
           </a:p>
         </p:txBody>
@@ -14509,7 +14509,7 @@
                 </a:solidFill>
                 <a:latin typeface="Aptos"/>
               </a:rPr>
-              <a:t>先 semantic lowering 为 causal/full 两次调用。论文材料报告相对 FlexAttention baseline 的 Nano training throughput +22%，Hopper FA3、GB200 NATTEN/CUTLASS。</a:t>
+              <a:t>收益属于 semantic lowering + FA3/varlen/runtime 组合，不改变模型候选质量。Nano/Super 训练 MFU 仅 0.23/0.30，说明 attention 之外仍有 loader、VAE、通信与 checkpoint 成本。</a:t>
             </a:r>
           </a:p>
         </p:txBody>
@@ -14522,7 +14522,7 @@
         </p:nvSpPr>
         <p:spPr>
           <a:xfrm>
-            <a:off x="530352" y="6437376"/>
+            <a:off x="530352" y="6236208"/>
             <a:ext cx="10607040" cy="164592"/>
           </a:xfrm>
           <a:prstGeom prst="rect">
@@ -14544,7 +14544,7 @@
                 </a:solidFill>
                 <a:latin typeface="Aptos"/>
               </a:rPr>
-              <a:t>Cosmos 3 local source: two-way attention infrastructure</a:t>
+              <a:t>Cosmos 3 Sec.5, Fig.14/16; cosmos-framework 3a5314b</a:t>
             </a:r>
           </a:p>
         </p:txBody>
@@ -14557,7 +14557,7 @@
         </p:nvSpPr>
         <p:spPr>
           <a:xfrm>
-            <a:off x="11356848" y="6409944"/>
+            <a:off x="11356848" y="6217920"/>
             <a:ext cx="320040" cy="182880"/>
           </a:xfrm>
           <a:prstGeom prst="rect">
@@ -14618,23 +14618,23 @@
         </p:nvSpPr>
         <p:spPr>
           <a:xfrm>
-            <a:off x="502920" y="256032"/>
-            <a:ext cx="10881360" cy="411480"/>
-          </a:xfrm>
-          <a:prstGeom prst="rect">
-            <a:avLst/>
-          </a:prstGeom>
-          <a:noFill/>
-        </p:spPr>
-        <p:txBody>
-          <a:bodyPr wrap="square" lIns="36576" rIns="36576" tIns="36576" bIns="36576" anchor="t">
-            <a:spAutoFit/>
-          </a:bodyPr>
-          <a:lstStyle/>
-          <a:p>
-            <a:pPr algn="l"/>
-            <a:r>
-              <a:rPr sz="2700" b="1">
+            <a:off x="502920" y="182880"/>
+            <a:ext cx="11109960" cy="640080"/>
+          </a:xfrm>
+          <a:prstGeom prst="rect">
+            <a:avLst/>
+          </a:prstGeom>
+          <a:noFill/>
+        </p:spPr>
+        <p:txBody>
+          <a:bodyPr wrap="square" lIns="36576" rIns="36576" tIns="36576" bIns="36576" anchor="t">
+            <a:spAutoFit/>
+          </a:bodyPr>
+          <a:lstStyle/>
+          <a:p>
+            <a:pPr algn="l"/>
+            <a:r>
+              <a:rPr sz="2400" b="1">
                 <a:solidFill>
                   <a:srgbClr val="17212B"/>
                 </a:solidFill>
@@ -14653,23 +14653,23 @@
         </p:nvSpPr>
         <p:spPr>
           <a:xfrm>
-            <a:off x="530352" y="804672"/>
-            <a:ext cx="10789920" cy="201168"/>
-          </a:xfrm>
-          <a:prstGeom prst="rect">
-            <a:avLst/>
-          </a:prstGeom>
-          <a:noFill/>
-        </p:spPr>
-        <p:txBody>
-          <a:bodyPr wrap="square" lIns="36576" rIns="36576" tIns="36576" bIns="36576" anchor="t">
-            <a:spAutoFit/>
-          </a:bodyPr>
-          <a:lstStyle/>
-          <a:p>
-            <a:pPr algn="l"/>
-            <a:r>
-              <a:rPr sz="900" b="0">
+            <a:off x="530352" y="896112"/>
+            <a:ext cx="10789920" cy="164592"/>
+          </a:xfrm>
+          <a:prstGeom prst="rect">
+            <a:avLst/>
+          </a:prstGeom>
+          <a:noFill/>
+        </p:spPr>
+        <p:txBody>
+          <a:bodyPr wrap="square" lIns="36576" rIns="36576" tIns="36576" bIns="36576" anchor="t">
+            <a:spAutoFit/>
+          </a:bodyPr>
+          <a:lstStyle/>
+          <a:p>
+            <a:pPr algn="l"/>
+            <a:r>
+              <a:rPr sz="800" b="0">
                 <a:solidFill>
                   <a:srgbClr val="52616B"/>
                 </a:solidFill>
@@ -15237,7 +15237,7 @@
         </p:nvSpPr>
         <p:spPr>
           <a:xfrm>
-            <a:off x="530352" y="6437376"/>
+            <a:off x="530352" y="6236208"/>
             <a:ext cx="10607040" cy="164592"/>
           </a:xfrm>
           <a:prstGeom prst="rect">
@@ -15272,7 +15272,7 @@
         </p:nvSpPr>
         <p:spPr>
           <a:xfrm>
-            <a:off x="11356848" y="6409944"/>
+            <a:off x="11356848" y="6217920"/>
             <a:ext cx="320040" cy="182880"/>
           </a:xfrm>
           <a:prstGeom prst="rect">
@@ -15333,23 +15333,23 @@
         </p:nvSpPr>
         <p:spPr>
           <a:xfrm>
-            <a:off x="502920" y="256032"/>
-            <a:ext cx="10881360" cy="411480"/>
-          </a:xfrm>
-          <a:prstGeom prst="rect">
-            <a:avLst/>
-          </a:prstGeom>
-          <a:noFill/>
-        </p:spPr>
-        <p:txBody>
-          <a:bodyPr wrap="square" lIns="36576" rIns="36576" tIns="36576" bIns="36576" anchor="t">
-            <a:spAutoFit/>
-          </a:bodyPr>
-          <a:lstStyle/>
-          <a:p>
-            <a:pPr algn="l"/>
-            <a:r>
-              <a:rPr sz="2700" b="1">
+            <a:off x="502920" y="182880"/>
+            <a:ext cx="11109960" cy="640080"/>
+          </a:xfrm>
+          <a:prstGeom prst="rect">
+            <a:avLst/>
+          </a:prstGeom>
+          <a:noFill/>
+        </p:spPr>
+        <p:txBody>
+          <a:bodyPr wrap="square" lIns="36576" rIns="36576" tIns="36576" bIns="36576" anchor="t">
+            <a:spAutoFit/>
+          </a:bodyPr>
+          <a:lstStyle/>
+          <a:p>
+            <a:pPr algn="l"/>
+            <a:r>
+              <a:rPr sz="2400" b="1">
                 <a:solidFill>
                   <a:srgbClr val="17212B"/>
                 </a:solidFill>
@@ -15368,23 +15368,23 @@
         </p:nvSpPr>
         <p:spPr>
           <a:xfrm>
-            <a:off x="530352" y="804672"/>
-            <a:ext cx="10789920" cy="201168"/>
-          </a:xfrm>
-          <a:prstGeom prst="rect">
-            <a:avLst/>
-          </a:prstGeom>
-          <a:noFill/>
-        </p:spPr>
-        <p:txBody>
-          <a:bodyPr wrap="square" lIns="36576" rIns="36576" tIns="36576" bIns="36576" anchor="t">
-            <a:spAutoFit/>
-          </a:bodyPr>
-          <a:lstStyle/>
-          <a:p>
-            <a:pPr algn="l"/>
-            <a:r>
-              <a:rPr sz="900" b="0">
+            <a:off x="530352" y="896112"/>
+            <a:ext cx="10789920" cy="164592"/>
+          </a:xfrm>
+          <a:prstGeom prst="rect">
+            <a:avLst/>
+          </a:prstGeom>
+          <a:noFill/>
+        </p:spPr>
+        <p:txBody>
+          <a:bodyPr wrap="square" lIns="36576" rIns="36576" tIns="36576" bIns="36576" anchor="t">
+            <a:spAutoFit/>
+          </a:bodyPr>
+          <a:lstStyle/>
+          <a:p>
+            <a:pPr algn="l"/>
+            <a:r>
+              <a:rPr sz="800" b="0">
                 <a:solidFill>
                   <a:srgbClr val="52616B"/>
                 </a:solidFill>
@@ -15952,7 +15952,7 @@
         </p:nvSpPr>
         <p:spPr>
           <a:xfrm>
-            <a:off x="530352" y="6437376"/>
+            <a:off x="530352" y="6236208"/>
             <a:ext cx="10607040" cy="164592"/>
           </a:xfrm>
           <a:prstGeom prst="rect">
@@ -15987,7 +15987,7 @@
         </p:nvSpPr>
         <p:spPr>
           <a:xfrm>
-            <a:off x="11356848" y="6409944"/>
+            <a:off x="11356848" y="6217920"/>
             <a:ext cx="320040" cy="182880"/>
           </a:xfrm>
           <a:prstGeom prst="rect">
@@ -16048,23 +16048,23 @@
         </p:nvSpPr>
         <p:spPr>
           <a:xfrm>
-            <a:off x="502920" y="256032"/>
-            <a:ext cx="10881360" cy="411480"/>
-          </a:xfrm>
-          <a:prstGeom prst="rect">
-            <a:avLst/>
-          </a:prstGeom>
-          <a:noFill/>
-        </p:spPr>
-        <p:txBody>
-          <a:bodyPr wrap="square" lIns="36576" rIns="36576" tIns="36576" bIns="36576" anchor="t">
-            <a:spAutoFit/>
-          </a:bodyPr>
-          <a:lstStyle/>
-          <a:p>
-            <a:pPr algn="l"/>
-            <a:r>
-              <a:rPr sz="2700" b="1">
+            <a:off x="502920" y="182880"/>
+            <a:ext cx="11109960" cy="640080"/>
+          </a:xfrm>
+          <a:prstGeom prst="rect">
+            <a:avLst/>
+          </a:prstGeom>
+          <a:noFill/>
+        </p:spPr>
+        <p:txBody>
+          <a:bodyPr wrap="square" lIns="36576" rIns="36576" tIns="36576" bIns="36576" anchor="t">
+            <a:spAutoFit/>
+          </a:bodyPr>
+          <a:lstStyle/>
+          <a:p>
+            <a:pPr algn="l"/>
+            <a:r>
+              <a:rPr sz="2400" b="1">
                 <a:solidFill>
                   <a:srgbClr val="17212B"/>
                 </a:solidFill>
@@ -16083,23 +16083,23 @@
         </p:nvSpPr>
         <p:spPr>
           <a:xfrm>
-            <a:off x="530352" y="804672"/>
-            <a:ext cx="10789920" cy="201168"/>
-          </a:xfrm>
-          <a:prstGeom prst="rect">
-            <a:avLst/>
-          </a:prstGeom>
-          <a:noFill/>
-        </p:spPr>
-        <p:txBody>
-          <a:bodyPr wrap="square" lIns="36576" rIns="36576" tIns="36576" bIns="36576" anchor="t">
-            <a:spAutoFit/>
-          </a:bodyPr>
-          <a:lstStyle/>
-          <a:p>
-            <a:pPr algn="l"/>
-            <a:r>
-              <a:rPr sz="900" b="0">
+            <a:off x="530352" y="896112"/>
+            <a:ext cx="10789920" cy="164592"/>
+          </a:xfrm>
+          <a:prstGeom prst="rect">
+            <a:avLst/>
+          </a:prstGeom>
+          <a:noFill/>
+        </p:spPr>
+        <p:txBody>
+          <a:bodyPr wrap="square" lIns="36576" rIns="36576" tIns="36576" bIns="36576" anchor="t">
+            <a:spAutoFit/>
+          </a:bodyPr>
+          <a:lstStyle/>
+          <a:p>
+            <a:pPr algn="l"/>
+            <a:r>
+              <a:rPr sz="800" b="0">
                 <a:solidFill>
                   <a:srgbClr val="52616B"/>
                 </a:solidFill>
@@ -16667,7 +16667,7 @@
         </p:nvSpPr>
         <p:spPr>
           <a:xfrm>
-            <a:off x="530352" y="6437376"/>
+            <a:off x="530352" y="6236208"/>
             <a:ext cx="10607040" cy="164592"/>
           </a:xfrm>
           <a:prstGeom prst="rect">
@@ -16702,7 +16702,7 @@
         </p:nvSpPr>
         <p:spPr>
           <a:xfrm>
-            <a:off x="11356848" y="6409944"/>
+            <a:off x="11356848" y="6217920"/>
             <a:ext cx="320040" cy="182880"/>
           </a:xfrm>
           <a:prstGeom prst="rect">
@@ -16763,23 +16763,23 @@
         </p:nvSpPr>
         <p:spPr>
           <a:xfrm>
-            <a:off x="502920" y="256032"/>
-            <a:ext cx="10881360" cy="411480"/>
-          </a:xfrm>
-          <a:prstGeom prst="rect">
-            <a:avLst/>
-          </a:prstGeom>
-          <a:noFill/>
-        </p:spPr>
-        <p:txBody>
-          <a:bodyPr wrap="square" lIns="36576" rIns="36576" tIns="36576" bIns="36576" anchor="t">
-            <a:spAutoFit/>
-          </a:bodyPr>
-          <a:lstStyle/>
-          <a:p>
-            <a:pPr algn="l"/>
-            <a:r>
-              <a:rPr sz="2700" b="1">
+            <a:off x="502920" y="182880"/>
+            <a:ext cx="11109960" cy="640080"/>
+          </a:xfrm>
+          <a:prstGeom prst="rect">
+            <a:avLst/>
+          </a:prstGeom>
+          <a:noFill/>
+        </p:spPr>
+        <p:txBody>
+          <a:bodyPr wrap="square" lIns="36576" rIns="36576" tIns="36576" bIns="36576" anchor="t">
+            <a:spAutoFit/>
+          </a:bodyPr>
+          <a:lstStyle/>
+          <a:p>
+            <a:pPr algn="l"/>
+            <a:r>
+              <a:rPr sz="2400" b="1">
                 <a:solidFill>
                   <a:srgbClr val="17212B"/>
                 </a:solidFill>
@@ -16798,23 +16798,23 @@
         </p:nvSpPr>
         <p:spPr>
           <a:xfrm>
-            <a:off x="530352" y="804672"/>
-            <a:ext cx="10789920" cy="201168"/>
-          </a:xfrm>
-          <a:prstGeom prst="rect">
-            <a:avLst/>
-          </a:prstGeom>
-          <a:noFill/>
-        </p:spPr>
-        <p:txBody>
-          <a:bodyPr wrap="square" lIns="36576" rIns="36576" tIns="36576" bIns="36576" anchor="t">
-            <a:spAutoFit/>
-          </a:bodyPr>
-          <a:lstStyle/>
-          <a:p>
-            <a:pPr algn="l"/>
-            <a:r>
-              <a:rPr sz="900" b="0">
+            <a:off x="530352" y="896112"/>
+            <a:ext cx="10789920" cy="164592"/>
+          </a:xfrm>
+          <a:prstGeom prst="rect">
+            <a:avLst/>
+          </a:prstGeom>
+          <a:noFill/>
+        </p:spPr>
+        <p:txBody>
+          <a:bodyPr wrap="square" lIns="36576" rIns="36576" tIns="36576" bIns="36576" anchor="t">
+            <a:spAutoFit/>
+          </a:bodyPr>
+          <a:lstStyle/>
+          <a:p>
+            <a:pPr algn="l"/>
+            <a:r>
+              <a:rPr sz="800" b="0">
                 <a:solidFill>
                   <a:srgbClr val="52616B"/>
                 </a:solidFill>
@@ -17382,7 +17382,7 @@
         </p:nvSpPr>
         <p:spPr>
           <a:xfrm>
-            <a:off x="530352" y="6437376"/>
+            <a:off x="530352" y="6236208"/>
             <a:ext cx="10607040" cy="164592"/>
           </a:xfrm>
           <a:prstGeom prst="rect">
@@ -17417,7 +17417,7 @@
         </p:nvSpPr>
         <p:spPr>
           <a:xfrm>
-            <a:off x="11356848" y="6409944"/>
+            <a:off x="11356848" y="6217920"/>
             <a:ext cx="320040" cy="182880"/>
           </a:xfrm>
           <a:prstGeom prst="rect">

</xml_diff>